<commit_message>
Corregir tips y guion de pronunciación de can y can't
</commit_message>
<xml_diff>
--- a/microclase-can-cant-could.pptx
+++ b/microclase-can-cant-could.pptx
@@ -915,11 +915,11 @@
 14s | PAUSA: Repite la frase (5 segundos)
 19s | ES: Con she también usas can swim. Swim queda igual: sin to y sin ese final.
 28s | EN: She can swim.
-33s | ES: En una respuesta corta, can suele sonar claro. Escucha y repite.
+31s | ES: En una frase, can suena débil. En una respuesta corta, suena fuerte. Escucha y repite.
 39s | EN: Yes, I can.
 42s | PAUSA: Repite: Yes, I can. (3 segundos)
 Revelar bloque 2 a los 19s: She can swim.
-Revelar bloque 3 a los 33s: Can
+Revelar bloque 3 a los 31s: Can
 No prolongues esta escena si usas avance automático. Para ajustar al grupo, pausa la presentación.</a:t>
             </a:r>
             <a:endParaRPr lang="en-US" dirty="0"/>
@@ -1015,12 +1015,12 @@
 10s | EN: I can’t drive.
 14s | PAUSA: Repite sin añadir to (6 segundos)
 20s | ES: Can’t es la contracción de cannot. Las dos formas expresan la misma idea.
-28s | EN: I cannot drive.
-32s | ES: En este modelo estadounidense, escucha la consonante final de can’t. Presta atención al contraste.
+27s | EN: I cannot drive.
+30s | ES: En inglés estadounidense, la t de can’t casi no se oye. Fíjate en la vocal, que es más larga y fuerte.
 39s | EN: I can drive. I can’t drive.
 43s | PAUSA: Observa el contraste (2 segundos)
 Revelar bloque 2 a los 20s: I cannot drive.
-Revelar bloque 3 a los 32s: Can’t
+Revelar bloque 3 a los 30s: Can’t
 No prolongues esta escena si usas avance automático. Para ajustar al grupo, pausa la presentación.</a:t>
             </a:r>
             <a:endParaRPr lang="en-US" dirty="0"/>
@@ -6683,7 +6683,7 @@
         <p:spPr>
           <a:xfrm>
             <a:off x="548640" y="4434840"/>
-            <a:ext cx="11091672" cy="1188720"/>
+            <a:ext cx="11091672" cy="1252728"/>
           </a:xfrm>
           <a:prstGeom prst="roundRect">
             <a:avLst>
@@ -6709,8 +6709,8 @@
         </p:nvSpPr>
         <p:spPr>
           <a:xfrm>
-            <a:off x="749808" y="4526280"/>
-            <a:ext cx="2377440" cy="1005840"/>
+            <a:off x="749808" y="4535424"/>
+            <a:ext cx="2377440" cy="365760"/>
           </a:xfrm>
           <a:prstGeom prst="rect">
             <a:avLst/>
@@ -6751,8 +6751,8 @@
         </p:nvSpPr>
         <p:spPr>
           <a:xfrm>
-            <a:off x="3246120" y="4544568"/>
-            <a:ext cx="3657600" cy="969264"/>
+            <a:off x="3291840" y="4535424"/>
+            <a:ext cx="2743200" cy="365760"/>
           </a:xfrm>
           <a:prstGeom prst="rect">
             <a:avLst/>
@@ -6793,8 +6793,8 @@
         </p:nvSpPr>
         <p:spPr>
           <a:xfrm>
-            <a:off x="7132320" y="4526280"/>
-            <a:ext cx="4279392" cy="1005840"/>
+            <a:off x="749808" y="4983480"/>
+            <a:ext cx="10689336" cy="640080"/>
           </a:xfrm>
           <a:prstGeom prst="rect">
             <a:avLst/>
@@ -6821,7 +6821,7 @@
                 <a:ea typeface="Work Sans" pitchFamily="34" charset="-122"/>
                 <a:cs typeface="Work Sans" pitchFamily="34" charset="-120"/>
               </a:rPr>
-              <a:t>En una respuesta corta, can suele sonar claro.</a:t>
+              <a:t>En una frase, can suena débil: /kən/. En una respuesta corta, suena fuerte: /kæn/.</a:t>
             </a:r>
             <a:endParaRPr lang="en-US" sz="2400" dirty="0"/>
           </a:p>
@@ -6996,7 +6996,7 @@
                         <p:par>
                           <p:cTn id="16" fill="hold">
                             <p:stCondLst>
-                              <p:cond delay="33000"/>
+                              <p:cond delay="31000"/>
                             </p:stCondLst>
                             <p:childTnLst>
                               <p:par>
@@ -7032,7 +7032,7 @@
                         <p:par>
                           <p:cTn id="19" fill="hold">
                             <p:stCondLst>
-                              <p:cond delay="33000"/>
+                              <p:cond delay="31000"/>
                             </p:stCondLst>
                             <p:childTnLst>
                               <p:par>
@@ -7068,7 +7068,7 @@
                         <p:par>
                           <p:cTn id="22" fill="hold">
                             <p:stCondLst>
-                              <p:cond delay="33000"/>
+                              <p:cond delay="31000"/>
                             </p:stCondLst>
                             <p:childTnLst>
                               <p:par>
@@ -7104,7 +7104,7 @@
                         <p:par>
                           <p:cTn id="25" fill="hold">
                             <p:stCondLst>
-                              <p:cond delay="33000"/>
+                              <p:cond delay="31000"/>
                             </p:stCondLst>
                             <p:childTnLst>
                               <p:par>
@@ -7936,7 +7936,7 @@
         <p:spPr>
           <a:xfrm>
             <a:off x="548640" y="4434840"/>
-            <a:ext cx="11091672" cy="1188720"/>
+            <a:ext cx="11091672" cy="1252728"/>
           </a:xfrm>
           <a:prstGeom prst="roundRect">
             <a:avLst>
@@ -7962,8 +7962,8 @@
         </p:nvSpPr>
         <p:spPr>
           <a:xfrm>
-            <a:off x="749808" y="4526280"/>
-            <a:ext cx="2377440" cy="1005840"/>
+            <a:off x="749808" y="4535424"/>
+            <a:ext cx="2377440" cy="365760"/>
           </a:xfrm>
           <a:prstGeom prst="rect">
             <a:avLst/>
@@ -8004,8 +8004,8 @@
         </p:nvSpPr>
         <p:spPr>
           <a:xfrm>
-            <a:off x="3246120" y="4544568"/>
-            <a:ext cx="3657600" cy="969264"/>
+            <a:off x="3291840" y="4535424"/>
+            <a:ext cx="2743200" cy="365760"/>
           </a:xfrm>
           <a:prstGeom prst="rect">
             <a:avLst/>
@@ -8046,8 +8046,8 @@
         </p:nvSpPr>
         <p:spPr>
           <a:xfrm>
-            <a:off x="7132320" y="4526280"/>
-            <a:ext cx="4279392" cy="1005840"/>
+            <a:off x="749808" y="4983480"/>
+            <a:ext cx="10689336" cy="640080"/>
           </a:xfrm>
           <a:prstGeom prst="rect">
             <a:avLst/>
@@ -8074,7 +8074,7 @@
                 <a:ea typeface="Work Sans" pitchFamily="34" charset="-122"/>
                 <a:cs typeface="Work Sans" pitchFamily="34" charset="-120"/>
               </a:rPr>
-              <a:t>Modelo de inglés estadounidense. Escucha la consonante final.</a:t>
+              <a:t>En inglés estadounidense, can’t suena más fuerte y con la vocal más larga que can. La t casi no se oye.</a:t>
             </a:r>
             <a:endParaRPr lang="en-US" sz="2400" dirty="0"/>
           </a:p>
@@ -8249,7 +8249,7 @@
                         <p:par>
                           <p:cTn id="16" fill="hold">
                             <p:stCondLst>
-                              <p:cond delay="32000"/>
+                              <p:cond delay="30000"/>
                             </p:stCondLst>
                             <p:childTnLst>
                               <p:par>
@@ -8285,7 +8285,7 @@
                         <p:par>
                           <p:cTn id="19" fill="hold">
                             <p:stCondLst>
-                              <p:cond delay="32000"/>
+                              <p:cond delay="30000"/>
                             </p:stCondLst>
                             <p:childTnLst>
                               <p:par>
@@ -8321,7 +8321,7 @@
                         <p:par>
                           <p:cTn id="22" fill="hold">
                             <p:stCondLst>
-                              <p:cond delay="32000"/>
+                              <p:cond delay="30000"/>
                             </p:stCondLst>
                             <p:childTnLst>
                               <p:par>
@@ -8357,7 +8357,7 @@
                         <p:par>
                           <p:cTn id="25" fill="hold">
                             <p:stCondLst>
-                              <p:cond delay="32000"/>
+                              <p:cond delay="30000"/>
                             </p:stCondLst>
                             <p:childTnLst>
                               <p:par>

</xml_diff>